<commit_message>
Make RIE submission reproducible from public code + EBSSA data
- Add README.md, requirements.txt, and build_rie_submission.py one-command pipeline

- Add generate_sr_figures.py for in-repo SR conceptual figures

- Replace cross-repo figure paths in create_rie_docx.py and create_rie_pptx.py

- Seed torch/numpy for deterministic PI-DC-DVS; make evaluation_summary figure paths relative

- Exclude legacy submission dirs from public mirror and point sync-to-repos.yml to reproducibility branch

Co-Authored-By: Tatsuki Onishi <bougtoir@gmail.com>
</commit_message>
<xml_diff>
--- a/dvs_noise_inverse_problem/results_in_engineering_submission/figures_rie.pptx
+++ b/dvs_noise_inverse_problem/results_in_engineering_submission/figures_rie.pptx
@@ -3146,7 +3146,7 @@
         <p:spPr>
           <a:xfrm>
             <a:off x="609447" y="822960"/>
-            <a:ext cx="10972800" cy="3198102"/>
+            <a:ext cx="10972800" cy="3199174"/>
           </a:xfrm>
           <a:prstGeom prst="rect">
             <a:avLst/>
@@ -3161,7 +3161,7 @@
         </p:nvSpPr>
         <p:spPr>
           <a:xfrm>
-            <a:off x="457200" y="4158222"/>
+            <a:off x="457200" y="4159294"/>
             <a:ext cx="10972800" cy="1097280"/>
           </a:xfrm>
           <a:prstGeom prst="rect">
@@ -3235,7 +3235,7 @@
       </p:sp>
       <p:pic>
         <p:nvPicPr>
-          <p:cNvPr id="3" name="Picture 2" descr="fig6_demo.png"/>
+          <p:cNvPr id="3" name="Picture 2" descr="fig3_noise_inverse_demo.png"/>
           <p:cNvPicPr>
             <a:picLocks noChangeAspect="1"/>
           </p:cNvPicPr>
@@ -3249,8 +3249,8 @@
         </p:blipFill>
         <p:spPr>
           <a:xfrm>
-            <a:off x="2925695" y="822960"/>
-            <a:ext cx="6340305" cy="4572000"/>
+            <a:off x="2924458" y="822960"/>
+            <a:ext cx="6342779" cy="4572000"/>
           </a:xfrm>
           <a:prstGeom prst="rect">
             <a:avLst/>
@@ -3339,7 +3339,7 @@
       </p:sp>
       <p:pic>
         <p:nvPicPr>
-          <p:cNvPr id="3" name="Picture 2" descr="fig7_snr.png"/>
+          <p:cNvPr id="3" name="Picture 2" descr="fig4_sn_improvement.png"/>
           <p:cNvPicPr>
             <a:picLocks noChangeAspect="1"/>
           </p:cNvPicPr>
@@ -3354,7 +3354,7 @@
         <p:spPr>
           <a:xfrm>
             <a:off x="609447" y="822960"/>
-            <a:ext cx="10972800" cy="3512539"/>
+            <a:ext cx="10972800" cy="3505775"/>
           </a:xfrm>
           <a:prstGeom prst="rect">
             <a:avLst/>
@@ -3369,7 +3369,7 @@
         </p:nvSpPr>
         <p:spPr>
           <a:xfrm>
-            <a:off x="457200" y="4472659"/>
+            <a:off x="457200" y="4465895"/>
             <a:ext cx="10972800" cy="1097280"/>
           </a:xfrm>
           <a:prstGeom prst="rect">
@@ -3457,8 +3457,8 @@
         </p:blipFill>
         <p:spPr>
           <a:xfrm>
-            <a:off x="743918" y="822960"/>
-            <a:ext cx="10703858" cy="4572000"/>
+            <a:off x="746159" y="822960"/>
+            <a:ext cx="10699376" cy="4572000"/>
           </a:xfrm>
           <a:prstGeom prst="rect">
             <a:avLst/>
@@ -3547,7 +3547,7 @@
       </p:sp>
       <p:pic>
         <p:nvPicPr>
-          <p:cNvPr id="3" name="Picture 2" descr="fig1_pipeline.png"/>
+          <p:cNvPr id="3" name="Picture 2" descr="fig2_g3_pipeline_en.png"/>
           <p:cNvPicPr>
             <a:picLocks noChangeAspect="1"/>
           </p:cNvPicPr>
@@ -3665,8 +3665,8 @@
         </p:blipFill>
         <p:spPr>
           <a:xfrm>
-            <a:off x="3067774" y="822960"/>
-            <a:ext cx="6056147" cy="4572000"/>
+            <a:off x="3068442" y="822960"/>
+            <a:ext cx="6054810" cy="4572000"/>
           </a:xfrm>
           <a:prstGeom prst="rect">
             <a:avLst/>
@@ -3769,8 +3769,8 @@
         </p:blipFill>
         <p:spPr>
           <a:xfrm>
-            <a:off x="786500" y="822960"/>
-            <a:ext cx="10618694" cy="4572000"/>
+            <a:off x="781290" y="822960"/>
+            <a:ext cx="10629114" cy="4572000"/>
           </a:xfrm>
           <a:prstGeom prst="rect">
             <a:avLst/>
@@ -3873,8 +3873,8 @@
         </p:blipFill>
         <p:spPr>
           <a:xfrm>
-            <a:off x="3868463" y="822960"/>
-            <a:ext cx="4454769" cy="4572000"/>
+            <a:off x="3866509" y="822960"/>
+            <a:ext cx="4458676" cy="4572000"/>
           </a:xfrm>
           <a:prstGeom prst="rect">
             <a:avLst/>
@@ -3963,7 +3963,7 @@
       </p:sp>
       <p:pic>
         <p:nvPicPr>
-          <p:cNvPr id="3" name="Picture 2" descr="fig4_a5_simulation.png"/>
+          <p:cNvPr id="3" name="Picture 2" descr="fig6_a5_simulation.png"/>
           <p:cNvPicPr>
             <a:picLocks noChangeAspect="1"/>
           </p:cNvPicPr>
@@ -4067,7 +4067,7 @@
       </p:sp>
       <p:pic>
         <p:nvPicPr>
-          <p:cNvPr id="3" name="Picture 2" descr="fig3_evaluation.png"/>
+          <p:cNvPr id="3" name="Picture 2" descr="fig5_systematic_evaluation.png"/>
           <p:cNvPicPr>
             <a:picLocks noChangeAspect="1"/>
           </p:cNvPicPr>
@@ -4185,8 +4185,8 @@
         </p:blipFill>
         <p:spPr>
           <a:xfrm>
-            <a:off x="786500" y="822960"/>
-            <a:ext cx="10618694" cy="4572000"/>
+            <a:off x="779047" y="822960"/>
+            <a:ext cx="10633601" cy="4572000"/>
           </a:xfrm>
           <a:prstGeom prst="rect">
             <a:avLst/>

</xml_diff>